<commit_message>
feat: publicering på subdomän, auto-avstängning 2026-09-24, QR-kod och PLAN.md
- Ny workflow stang-av-2026-09-24.yml deployar stangd/ (stängt-sida utan API) 24 sep 2026
- Datumspärr i ordinarie deploy från 2026-09-25 så sajten inte öppnas igen av misstag
- QR-kod (PNG + SVG) till samhallsbyggare.projektledarpodden.se i docs/
- PLAN.md: CNAME i Cloudflare väntar på Mattias, sedan az staticwebapp hostname set
- Docs: CLAUDE.md, README.md, session-log, projekt-pptx; committar tidigare ocommittade pptx-filer

Co-Authored-By: Claude Fable 5.1 <noreply@anthropic.com>
</commit_message>
<xml_diff>
--- a/docs/Samhallsbyggarkartan-guide.pptx
+++ b/docs/Samhallsbyggarkartan-guide.pptx
@@ -5,13 +5,13 @@
     <p:sldMasterId id="2147483648" r:id="rId1"/>
   </p:sldMasterIdLst>
   <p:sldIdLst>
-    <p:sldId id="256" r:id="rId7"/>
-    <p:sldId id="257" r:id="rId8"/>
-    <p:sldId id="258" r:id="rId9"/>
-    <p:sldId id="259" r:id="rId10"/>
-    <p:sldId id="260" r:id="rId11"/>
+    <p:sldId id="256" r:id="rId2"/>
+    <p:sldId id="257" r:id="rId3"/>
+    <p:sldId id="258" r:id="rId4"/>
+    <p:sldId id="259" r:id="rId5"/>
+    <p:sldId id="260" r:id="rId6"/>
   </p:sldIdLst>
-  <p:sldSz cx="12191695" cy="6858000" type="screen4x3"/>
+  <p:sldSz cx="12192000" cy="6858000"/>
   <p:notesSz cx="6858000" cy="9144000"/>
   <p:defaultTextStyle>
     <a:defPPr>
@@ -108,6 +108,22 @@
       </a:defRPr>
     </a:lvl9pPr>
   </p:defaultTextStyle>
+  <p:extLst>
+    <p:ext uri="{EFAFB233-063F-42B5-8137-9DF3F51BA10A}">
+      <p15:sldGuideLst xmlns:p15="http://schemas.microsoft.com/office/powerpoint/2012/main">
+        <p15:guide id="1" orient="horz" pos="2160">
+          <p15:clr>
+            <a:srgbClr val="A4A3A4"/>
+          </p15:clr>
+        </p15:guide>
+        <p15:guide id="2" pos="2880">
+          <p15:clr>
+            <a:srgbClr val="A4A3A4"/>
+          </p15:clr>
+        </p15:guide>
+      </p15:sldGuideLst>
+    </p:ext>
+  </p:extLst>
 </p:presentation>
 </file>
 
@@ -149,10 +165,9 @@
           <a:lstStyle/>
           <a:p>
             <a:r>
-              <a:rPr lang="en-US" smtClean="0"/>
+              <a:rPr lang="en-US"/>
               <a:t>Click to edit Master title style</a:t>
             </a:r>
-            <a:endParaRPr lang="en-US"/>
           </a:p>
         </p:txBody>
       </p:sp>
@@ -268,10 +283,9 @@
           </a:lstStyle>
           <a:p>
             <a:r>
-              <a:rPr lang="en-US" smtClean="0"/>
+              <a:rPr lang="en-US"/>
               <a:t>Click to edit Master subtitle style</a:t>
             </a:r>
-            <a:endParaRPr lang="en-US"/>
           </a:p>
         </p:txBody>
       </p:sp>
@@ -292,7 +306,7 @@
           <a:p>
             <a:fld id="{5BCAD085-E8A6-8845-BD4E-CB4CCA059FC4}" type="datetimeFigureOut">
               <a:rPr lang="en-US" smtClean="0"/>
-              <a:t>1/27/13</a:t>
+              <a:t>7/6/2026</a:t>
             </a:fld>
             <a:endParaRPr lang="en-US"/>
           </a:p>
@@ -386,10 +400,9 @@
           <a:lstStyle/>
           <a:p>
             <a:r>
-              <a:rPr lang="en-US" smtClean="0"/>
+              <a:rPr lang="en-US"/>
               <a:t>Click to edit Master title style</a:t>
             </a:r>
-            <a:endParaRPr lang="en-US"/>
           </a:p>
         </p:txBody>
       </p:sp>
@@ -410,38 +423,37 @@
           <a:p>
             <a:pPr lvl="0"/>
             <a:r>
-              <a:rPr lang="en-US" smtClean="0"/>
+              <a:rPr lang="en-US"/>
               <a:t>Click to edit Master text styles</a:t>
             </a:r>
           </a:p>
           <a:p>
             <a:pPr lvl="1"/>
             <a:r>
-              <a:rPr lang="en-US" smtClean="0"/>
+              <a:rPr lang="en-US"/>
               <a:t>Second level</a:t>
             </a:r>
           </a:p>
           <a:p>
             <a:pPr lvl="2"/>
             <a:r>
-              <a:rPr lang="en-US" smtClean="0"/>
+              <a:rPr lang="en-US"/>
               <a:t>Third level</a:t>
             </a:r>
           </a:p>
           <a:p>
             <a:pPr lvl="3"/>
             <a:r>
-              <a:rPr lang="en-US" smtClean="0"/>
+              <a:rPr lang="en-US"/>
               <a:t>Fourth level</a:t>
             </a:r>
           </a:p>
           <a:p>
             <a:pPr lvl="4"/>
             <a:r>
-              <a:rPr lang="en-US" smtClean="0"/>
+              <a:rPr lang="en-US"/>
               <a:t>Fifth level</a:t>
             </a:r>
-            <a:endParaRPr lang="en-US"/>
           </a:p>
         </p:txBody>
       </p:sp>
@@ -462,7 +474,7 @@
           <a:p>
             <a:fld id="{5BCAD085-E8A6-8845-BD4E-CB4CCA059FC4}" type="datetimeFigureOut">
               <a:rPr lang="en-US" smtClean="0"/>
-              <a:t>1/27/13</a:t>
+              <a:t>7/6/2026</a:t>
             </a:fld>
             <a:endParaRPr lang="en-US"/>
           </a:p>
@@ -561,10 +573,9 @@
           <a:lstStyle/>
           <a:p>
             <a:r>
-              <a:rPr lang="en-US" smtClean="0"/>
+              <a:rPr lang="en-US"/>
               <a:t>Click to edit Master title style</a:t>
             </a:r>
-            <a:endParaRPr lang="en-US"/>
           </a:p>
         </p:txBody>
       </p:sp>
@@ -590,38 +601,37 @@
           <a:p>
             <a:pPr lvl="0"/>
             <a:r>
-              <a:rPr lang="en-US" smtClean="0"/>
+              <a:rPr lang="en-US"/>
               <a:t>Click to edit Master text styles</a:t>
             </a:r>
           </a:p>
           <a:p>
             <a:pPr lvl="1"/>
             <a:r>
-              <a:rPr lang="en-US" smtClean="0"/>
+              <a:rPr lang="en-US"/>
               <a:t>Second level</a:t>
             </a:r>
           </a:p>
           <a:p>
             <a:pPr lvl="2"/>
             <a:r>
-              <a:rPr lang="en-US" smtClean="0"/>
+              <a:rPr lang="en-US"/>
               <a:t>Third level</a:t>
             </a:r>
           </a:p>
           <a:p>
             <a:pPr lvl="3"/>
             <a:r>
-              <a:rPr lang="en-US" smtClean="0"/>
+              <a:rPr lang="en-US"/>
               <a:t>Fourth level</a:t>
             </a:r>
           </a:p>
           <a:p>
             <a:pPr lvl="4"/>
             <a:r>
-              <a:rPr lang="en-US" smtClean="0"/>
+              <a:rPr lang="en-US"/>
               <a:t>Fifth level</a:t>
             </a:r>
-            <a:endParaRPr lang="en-US"/>
           </a:p>
         </p:txBody>
       </p:sp>
@@ -642,7 +652,7 @@
           <a:p>
             <a:fld id="{5BCAD085-E8A6-8845-BD4E-CB4CCA059FC4}" type="datetimeFigureOut">
               <a:rPr lang="en-US" smtClean="0"/>
-              <a:t>1/27/13</a:t>
+              <a:t>7/6/2026</a:t>
             </a:fld>
             <a:endParaRPr lang="en-US"/>
           </a:p>
@@ -736,10 +746,9 @@
           <a:lstStyle/>
           <a:p>
             <a:r>
-              <a:rPr lang="en-US" smtClean="0"/>
+              <a:rPr lang="en-US"/>
               <a:t>Click to edit Master title style</a:t>
             </a:r>
-            <a:endParaRPr lang="en-US"/>
           </a:p>
         </p:txBody>
       </p:sp>
@@ -760,38 +769,37 @@
           <a:p>
             <a:pPr lvl="0"/>
             <a:r>
-              <a:rPr lang="en-US" smtClean="0"/>
+              <a:rPr lang="en-US"/>
               <a:t>Click to edit Master text styles</a:t>
             </a:r>
           </a:p>
           <a:p>
             <a:pPr lvl="1"/>
             <a:r>
-              <a:rPr lang="en-US" smtClean="0"/>
+              <a:rPr lang="en-US"/>
               <a:t>Second level</a:t>
             </a:r>
           </a:p>
           <a:p>
             <a:pPr lvl="2"/>
             <a:r>
-              <a:rPr lang="en-US" smtClean="0"/>
+              <a:rPr lang="en-US"/>
               <a:t>Third level</a:t>
             </a:r>
           </a:p>
           <a:p>
             <a:pPr lvl="3"/>
             <a:r>
-              <a:rPr lang="en-US" smtClean="0"/>
+              <a:rPr lang="en-US"/>
               <a:t>Fourth level</a:t>
             </a:r>
           </a:p>
           <a:p>
             <a:pPr lvl="4"/>
             <a:r>
-              <a:rPr lang="en-US" smtClean="0"/>
+              <a:rPr lang="en-US"/>
               <a:t>Fifth level</a:t>
             </a:r>
-            <a:endParaRPr lang="en-US"/>
           </a:p>
         </p:txBody>
       </p:sp>
@@ -812,7 +820,7 @@
           <a:p>
             <a:fld id="{5BCAD085-E8A6-8845-BD4E-CB4CCA059FC4}" type="datetimeFigureOut">
               <a:rPr lang="en-US" smtClean="0"/>
-              <a:t>1/27/13</a:t>
+              <a:t>7/6/2026</a:t>
             </a:fld>
             <a:endParaRPr lang="en-US"/>
           </a:p>
@@ -915,10 +923,9 @@
           </a:lstStyle>
           <a:p>
             <a:r>
-              <a:rPr lang="en-US" smtClean="0"/>
+              <a:rPr lang="en-US"/>
               <a:t>Click to edit Master title style</a:t>
             </a:r>
-            <a:endParaRPr lang="en-US"/>
           </a:p>
         </p:txBody>
       </p:sp>
@@ -1035,7 +1042,7 @@
           <a:p>
             <a:pPr lvl="0"/>
             <a:r>
-              <a:rPr lang="en-US" smtClean="0"/>
+              <a:rPr lang="en-US"/>
               <a:t>Click to edit Master text styles</a:t>
             </a:r>
           </a:p>
@@ -1058,7 +1065,7 @@
           <a:p>
             <a:fld id="{5BCAD085-E8A6-8845-BD4E-CB4CCA059FC4}" type="datetimeFigureOut">
               <a:rPr lang="en-US" smtClean="0"/>
-              <a:t>1/27/13</a:t>
+              <a:t>7/6/2026</a:t>
             </a:fld>
             <a:endParaRPr lang="en-US"/>
           </a:p>
@@ -1152,10 +1159,9 @@
           <a:lstStyle/>
           <a:p>
             <a:r>
-              <a:rPr lang="en-US" smtClean="0"/>
+              <a:rPr lang="en-US"/>
               <a:t>Click to edit Master title style</a:t>
             </a:r>
-            <a:endParaRPr lang="en-US"/>
           </a:p>
         </p:txBody>
       </p:sp>
@@ -1209,38 +1215,37 @@
           <a:p>
             <a:pPr lvl="0"/>
             <a:r>
-              <a:rPr lang="en-US" smtClean="0"/>
+              <a:rPr lang="en-US"/>
               <a:t>Click to edit Master text styles</a:t>
             </a:r>
           </a:p>
           <a:p>
             <a:pPr lvl="1"/>
             <a:r>
-              <a:rPr lang="en-US" smtClean="0"/>
+              <a:rPr lang="en-US"/>
               <a:t>Second level</a:t>
             </a:r>
           </a:p>
           <a:p>
             <a:pPr lvl="2"/>
             <a:r>
-              <a:rPr lang="en-US" smtClean="0"/>
+              <a:rPr lang="en-US"/>
               <a:t>Third level</a:t>
             </a:r>
           </a:p>
           <a:p>
             <a:pPr lvl="3"/>
             <a:r>
-              <a:rPr lang="en-US" smtClean="0"/>
+              <a:rPr lang="en-US"/>
               <a:t>Fourth level</a:t>
             </a:r>
           </a:p>
           <a:p>
             <a:pPr lvl="4"/>
             <a:r>
-              <a:rPr lang="en-US" smtClean="0"/>
+              <a:rPr lang="en-US"/>
               <a:t>Fifth level</a:t>
             </a:r>
-            <a:endParaRPr lang="en-US"/>
           </a:p>
         </p:txBody>
       </p:sp>
@@ -1294,38 +1299,37 @@
           <a:p>
             <a:pPr lvl="0"/>
             <a:r>
-              <a:rPr lang="en-US" smtClean="0"/>
+              <a:rPr lang="en-US"/>
               <a:t>Click to edit Master text styles</a:t>
             </a:r>
           </a:p>
           <a:p>
             <a:pPr lvl="1"/>
             <a:r>
-              <a:rPr lang="en-US" smtClean="0"/>
+              <a:rPr lang="en-US"/>
               <a:t>Second level</a:t>
             </a:r>
           </a:p>
           <a:p>
             <a:pPr lvl="2"/>
             <a:r>
-              <a:rPr lang="en-US" smtClean="0"/>
+              <a:rPr lang="en-US"/>
               <a:t>Third level</a:t>
             </a:r>
           </a:p>
           <a:p>
             <a:pPr lvl="3"/>
             <a:r>
-              <a:rPr lang="en-US" smtClean="0"/>
+              <a:rPr lang="en-US"/>
               <a:t>Fourth level</a:t>
             </a:r>
           </a:p>
           <a:p>
             <a:pPr lvl="4"/>
             <a:r>
-              <a:rPr lang="en-US" smtClean="0"/>
+              <a:rPr lang="en-US"/>
               <a:t>Fifth level</a:t>
             </a:r>
-            <a:endParaRPr lang="en-US"/>
           </a:p>
         </p:txBody>
       </p:sp>
@@ -1346,7 +1350,7 @@
           <a:p>
             <a:fld id="{5BCAD085-E8A6-8845-BD4E-CB4CCA059FC4}" type="datetimeFigureOut">
               <a:rPr lang="en-US" smtClean="0"/>
-              <a:t>1/27/13</a:t>
+              <a:t>7/6/2026</a:t>
             </a:fld>
             <a:endParaRPr lang="en-US"/>
           </a:p>
@@ -1444,10 +1448,9 @@
           </a:lstStyle>
           <a:p>
             <a:r>
-              <a:rPr lang="en-US" smtClean="0"/>
+              <a:rPr lang="en-US"/>
               <a:t>Click to edit Master title style</a:t>
             </a:r>
-            <a:endParaRPr lang="en-US"/>
           </a:p>
         </p:txBody>
       </p:sp>
@@ -1510,7 +1513,7 @@
           <a:p>
             <a:pPr lvl="0"/>
             <a:r>
-              <a:rPr lang="en-US" smtClean="0"/>
+              <a:rPr lang="en-US"/>
               <a:t>Click to edit Master text styles</a:t>
             </a:r>
           </a:p>
@@ -1566,38 +1569,37 @@
           <a:p>
             <a:pPr lvl="0"/>
             <a:r>
-              <a:rPr lang="en-US" smtClean="0"/>
+              <a:rPr lang="en-US"/>
               <a:t>Click to edit Master text styles</a:t>
             </a:r>
           </a:p>
           <a:p>
             <a:pPr lvl="1"/>
             <a:r>
-              <a:rPr lang="en-US" smtClean="0"/>
+              <a:rPr lang="en-US"/>
               <a:t>Second level</a:t>
             </a:r>
           </a:p>
           <a:p>
             <a:pPr lvl="2"/>
             <a:r>
-              <a:rPr lang="en-US" smtClean="0"/>
+              <a:rPr lang="en-US"/>
               <a:t>Third level</a:t>
             </a:r>
           </a:p>
           <a:p>
             <a:pPr lvl="3"/>
             <a:r>
-              <a:rPr lang="en-US" smtClean="0"/>
+              <a:rPr lang="en-US"/>
               <a:t>Fourth level</a:t>
             </a:r>
           </a:p>
           <a:p>
             <a:pPr lvl="4"/>
             <a:r>
-              <a:rPr lang="en-US" smtClean="0"/>
+              <a:rPr lang="en-US"/>
               <a:t>Fifth level</a:t>
             </a:r>
-            <a:endParaRPr lang="en-US"/>
           </a:p>
         </p:txBody>
       </p:sp>
@@ -1660,7 +1662,7 @@
           <a:p>
             <a:pPr lvl="0"/>
             <a:r>
-              <a:rPr lang="en-US" smtClean="0"/>
+              <a:rPr lang="en-US"/>
               <a:t>Click to edit Master text styles</a:t>
             </a:r>
           </a:p>
@@ -1716,38 +1718,37 @@
           <a:p>
             <a:pPr lvl="0"/>
             <a:r>
-              <a:rPr lang="en-US" smtClean="0"/>
+              <a:rPr lang="en-US"/>
               <a:t>Click to edit Master text styles</a:t>
             </a:r>
           </a:p>
           <a:p>
             <a:pPr lvl="1"/>
             <a:r>
-              <a:rPr lang="en-US" smtClean="0"/>
+              <a:rPr lang="en-US"/>
               <a:t>Second level</a:t>
             </a:r>
           </a:p>
           <a:p>
             <a:pPr lvl="2"/>
             <a:r>
-              <a:rPr lang="en-US" smtClean="0"/>
+              <a:rPr lang="en-US"/>
               <a:t>Third level</a:t>
             </a:r>
           </a:p>
           <a:p>
             <a:pPr lvl="3"/>
             <a:r>
-              <a:rPr lang="en-US" smtClean="0"/>
+              <a:rPr lang="en-US"/>
               <a:t>Fourth level</a:t>
             </a:r>
           </a:p>
           <a:p>
             <a:pPr lvl="4"/>
             <a:r>
-              <a:rPr lang="en-US" smtClean="0"/>
+              <a:rPr lang="en-US"/>
               <a:t>Fifth level</a:t>
             </a:r>
-            <a:endParaRPr lang="en-US"/>
           </a:p>
         </p:txBody>
       </p:sp>
@@ -1768,7 +1769,7 @@
           <a:p>
             <a:fld id="{5BCAD085-E8A6-8845-BD4E-CB4CCA059FC4}" type="datetimeFigureOut">
               <a:rPr lang="en-US" smtClean="0"/>
-              <a:t>1/27/13</a:t>
+              <a:t>7/6/2026</a:t>
             </a:fld>
             <a:endParaRPr lang="en-US"/>
           </a:p>
@@ -1862,10 +1863,9 @@
           <a:lstStyle/>
           <a:p>
             <a:r>
-              <a:rPr lang="en-US" smtClean="0"/>
+              <a:rPr lang="en-US"/>
               <a:t>Click to edit Master title style</a:t>
             </a:r>
-            <a:endParaRPr lang="en-US"/>
           </a:p>
         </p:txBody>
       </p:sp>
@@ -1886,7 +1886,7 @@
           <a:p>
             <a:fld id="{5BCAD085-E8A6-8845-BD4E-CB4CCA059FC4}" type="datetimeFigureOut">
               <a:rPr lang="en-US" smtClean="0"/>
-              <a:t>1/27/13</a:t>
+              <a:t>7/6/2026</a:t>
             </a:fld>
             <a:endParaRPr lang="en-US"/>
           </a:p>
@@ -1981,7 +1981,7 @@
           <a:p>
             <a:fld id="{5BCAD085-E8A6-8845-BD4E-CB4CCA059FC4}" type="datetimeFigureOut">
               <a:rPr lang="en-US" smtClean="0"/>
-              <a:t>1/27/13</a:t>
+              <a:t>7/6/2026</a:t>
             </a:fld>
             <a:endParaRPr lang="en-US"/>
           </a:p>
@@ -2084,10 +2084,9 @@
           </a:lstStyle>
           <a:p>
             <a:r>
-              <a:rPr lang="en-US" smtClean="0"/>
+              <a:rPr lang="en-US"/>
               <a:t>Click to edit Master title style</a:t>
             </a:r>
-            <a:endParaRPr lang="en-US"/>
           </a:p>
         </p:txBody>
       </p:sp>
@@ -2141,38 +2140,37 @@
           <a:p>
             <a:pPr lvl="0"/>
             <a:r>
-              <a:rPr lang="en-US" smtClean="0"/>
+              <a:rPr lang="en-US"/>
               <a:t>Click to edit Master text styles</a:t>
             </a:r>
           </a:p>
           <a:p>
             <a:pPr lvl="1"/>
             <a:r>
-              <a:rPr lang="en-US" smtClean="0"/>
+              <a:rPr lang="en-US"/>
               <a:t>Second level</a:t>
             </a:r>
           </a:p>
           <a:p>
             <a:pPr lvl="2"/>
             <a:r>
-              <a:rPr lang="en-US" smtClean="0"/>
+              <a:rPr lang="en-US"/>
               <a:t>Third level</a:t>
             </a:r>
           </a:p>
           <a:p>
             <a:pPr lvl="3"/>
             <a:r>
-              <a:rPr lang="en-US" smtClean="0"/>
+              <a:rPr lang="en-US"/>
               <a:t>Fourth level</a:t>
             </a:r>
           </a:p>
           <a:p>
             <a:pPr lvl="4"/>
             <a:r>
-              <a:rPr lang="en-US" smtClean="0"/>
+              <a:rPr lang="en-US"/>
               <a:t>Fifth level</a:t>
             </a:r>
-            <a:endParaRPr lang="en-US"/>
           </a:p>
         </p:txBody>
       </p:sp>
@@ -2235,7 +2233,7 @@
           <a:p>
             <a:pPr lvl="0"/>
             <a:r>
-              <a:rPr lang="en-US" smtClean="0"/>
+              <a:rPr lang="en-US"/>
               <a:t>Click to edit Master text styles</a:t>
             </a:r>
           </a:p>
@@ -2258,7 +2256,7 @@
           <a:p>
             <a:fld id="{5BCAD085-E8A6-8845-BD4E-CB4CCA059FC4}" type="datetimeFigureOut">
               <a:rPr lang="en-US" smtClean="0"/>
-              <a:t>1/27/13</a:t>
+              <a:t>7/6/2026</a:t>
             </a:fld>
             <a:endParaRPr lang="en-US"/>
           </a:p>
@@ -2361,10 +2359,9 @@
           </a:lstStyle>
           <a:p>
             <a:r>
-              <a:rPr lang="en-US" smtClean="0"/>
+              <a:rPr lang="en-US"/>
               <a:t>Click to edit Master title style</a:t>
             </a:r>
-            <a:endParaRPr lang="en-US"/>
           </a:p>
         </p:txBody>
       </p:sp>
@@ -2488,7 +2485,7 @@
           <a:p>
             <a:pPr lvl="0"/>
             <a:r>
-              <a:rPr lang="en-US" smtClean="0"/>
+              <a:rPr lang="en-US"/>
               <a:t>Click to edit Master text styles</a:t>
             </a:r>
           </a:p>
@@ -2511,7 +2508,7 @@
           <a:p>
             <a:fld id="{5BCAD085-E8A6-8845-BD4E-CB4CCA059FC4}" type="datetimeFigureOut">
               <a:rPr lang="en-US" smtClean="0"/>
-              <a:t>1/27/13</a:t>
+              <a:t>7/6/2026</a:t>
             </a:fld>
             <a:endParaRPr lang="en-US"/>
           </a:p>
@@ -2620,10 +2617,9 @@
           <a:lstStyle/>
           <a:p>
             <a:r>
-              <a:rPr lang="en-US" smtClean="0"/>
+              <a:rPr lang="en-US"/>
               <a:t>Click to edit Master title style</a:t>
             </a:r>
-            <a:endParaRPr lang="en-US"/>
           </a:p>
         </p:txBody>
       </p:sp>
@@ -2654,38 +2650,37 @@
           <a:p>
             <a:pPr lvl="0"/>
             <a:r>
-              <a:rPr lang="en-US" smtClean="0"/>
+              <a:rPr lang="en-US"/>
               <a:t>Click to edit Master text styles</a:t>
             </a:r>
           </a:p>
           <a:p>
             <a:pPr lvl="1"/>
             <a:r>
-              <a:rPr lang="en-US" smtClean="0"/>
+              <a:rPr lang="en-US"/>
               <a:t>Second level</a:t>
             </a:r>
           </a:p>
           <a:p>
             <a:pPr lvl="2"/>
             <a:r>
-              <a:rPr lang="en-US" smtClean="0"/>
+              <a:rPr lang="en-US"/>
               <a:t>Third level</a:t>
             </a:r>
           </a:p>
           <a:p>
             <a:pPr lvl="3"/>
             <a:r>
-              <a:rPr lang="en-US" smtClean="0"/>
+              <a:rPr lang="en-US"/>
               <a:t>Fourth level</a:t>
             </a:r>
           </a:p>
           <a:p>
             <a:pPr lvl="4"/>
             <a:r>
-              <a:rPr lang="en-US" smtClean="0"/>
+              <a:rPr lang="en-US"/>
               <a:t>Fifth level</a:t>
             </a:r>
-            <a:endParaRPr lang="en-US"/>
           </a:p>
         </p:txBody>
       </p:sp>
@@ -2724,7 +2719,7 @@
           <a:p>
             <a:fld id="{5BCAD085-E8A6-8845-BD4E-CB4CCA059FC4}" type="datetimeFigureOut">
               <a:rPr lang="en-US" smtClean="0"/>
-              <a:t>1/27/13</a:t>
+              <a:t>7/6/2026</a:t>
             </a:fld>
             <a:endParaRPr lang="en-US"/>
           </a:p>
@@ -3083,7 +3078,7 @@
 </file>
 
 <file path=ppt/slides/slide1.xml><?xml version="1.0" encoding="utf-8"?>
-<p:sld xmlns:a="http://schemas.openxmlformats.org/drawingml/2006/main" xmlns:p="http://schemas.openxmlformats.org/presentationml/2006/main" xmlns:r="http://schemas.openxmlformats.org/officeDocument/2006/relationships">
+<p:sld xmlns:a="http://schemas.openxmlformats.org/drawingml/2006/main" xmlns:r="http://schemas.openxmlformats.org/officeDocument/2006/relationships" xmlns:p="http://schemas.openxmlformats.org/presentationml/2006/main">
   <p:cSld>
     <p:bg>
       <p:bgPr>
@@ -3099,7 +3094,14 @@
         <p:cNvGrpSpPr/>
         <p:nvPr/>
       </p:nvGrpSpPr>
-      <p:grpSpPr/>
+      <p:grpSpPr>
+        <a:xfrm>
+          <a:off x="0" y="0"/>
+          <a:ext cx="0" cy="0"/>
+          <a:chOff x="0" y="0"/>
+          <a:chExt cx="0" cy="0"/>
+        </a:xfrm>
+      </p:grpSpPr>
       <p:sp>
         <p:nvSpPr>
           <p:cNvPr id="2" name="Rectangle 1"/>
@@ -3141,6 +3143,7 @@
           <a:lstStyle/>
           <a:p>
             <a:pPr algn="ctr"/>
+            <a:endParaRPr/>
           </a:p>
         </p:txBody>
       </p:sp>
@@ -3187,6 +3190,7 @@
           <a:lstStyle/>
           <a:p>
             <a:pPr algn="ctr"/>
+            <a:endParaRPr/>
           </a:p>
         </p:txBody>
       </p:sp>
@@ -3207,7 +3211,7 @@
           <a:noFill/>
         </p:spPr>
         <p:txBody>
-          <a:bodyPr wrap="square" anchor="t" lIns="0" rIns="0" tIns="0" bIns="0">
+          <a:bodyPr wrap="square" lIns="0" tIns="0" rIns="0" bIns="0" anchor="t">
             <a:spAutoFit/>
           </a:bodyPr>
           <a:lstStyle/>
@@ -3249,7 +3253,7 @@
           <a:noFill/>
         </p:spPr>
         <p:txBody>
-          <a:bodyPr wrap="square" anchor="t" lIns="0" rIns="0" tIns="0" bIns="0">
+          <a:bodyPr wrap="square" lIns="0" tIns="0" rIns="0" bIns="0" anchor="t">
             <a:spAutoFit/>
           </a:bodyPr>
           <a:lstStyle/>
@@ -3291,7 +3295,7 @@
           <a:noFill/>
         </p:spPr>
         <p:txBody>
-          <a:bodyPr wrap="square" anchor="t" lIns="0" rIns="0" tIns="0" bIns="0">
+          <a:bodyPr wrap="square" lIns="0" tIns="0" rIns="0" bIns="0" anchor="t">
             <a:spAutoFit/>
           </a:bodyPr>
           <a:lstStyle/>
@@ -3355,12 +3359,12 @@
           </a:fontRef>
         </p:style>
         <p:txBody>
-          <a:bodyPr rtlCol="0" anchor="ctr" lIns="177800"/>
+          <a:bodyPr lIns="177800" rtlCol="0" anchor="ctr"/>
           <a:lstStyle/>
           <a:p>
             <a:pPr algn="ctr"/>
             <a:r>
-              <a:rPr sz="1600" b="1">
+              <a:rPr sz="1600" b="1" dirty="0">
                 <a:solidFill>
                   <a:srgbClr val="FFFFFF"/>
                 </a:solidFill>
@@ -3388,7 +3392,7 @@
           <a:noFill/>
         </p:spPr>
         <p:txBody>
-          <a:bodyPr wrap="square" anchor="t" lIns="0" rIns="0" tIns="0" bIns="0">
+          <a:bodyPr wrap="square" lIns="0" tIns="0" rIns="0" bIns="0" anchor="t">
             <a:spAutoFit/>
           </a:bodyPr>
           <a:lstStyle/>
@@ -3422,7 +3426,7 @@
 </file>
 
 <file path=ppt/slides/slide2.xml><?xml version="1.0" encoding="utf-8"?>
-<p:sld xmlns:a="http://schemas.openxmlformats.org/drawingml/2006/main" xmlns:p="http://schemas.openxmlformats.org/presentationml/2006/main" xmlns:r="http://schemas.openxmlformats.org/officeDocument/2006/relationships">
+<p:sld xmlns:a="http://schemas.openxmlformats.org/drawingml/2006/main" xmlns:r="http://schemas.openxmlformats.org/officeDocument/2006/relationships" xmlns:p="http://schemas.openxmlformats.org/presentationml/2006/main">
   <p:cSld>
     <p:bg>
       <p:bgPr>
@@ -3438,7 +3442,14 @@
         <p:cNvGrpSpPr/>
         <p:nvPr/>
       </p:nvGrpSpPr>
-      <p:grpSpPr/>
+      <p:grpSpPr>
+        <a:xfrm>
+          <a:off x="0" y="0"/>
+          <a:ext cx="0" cy="0"/>
+          <a:chOff x="0" y="0"/>
+          <a:chExt cx="0" cy="0"/>
+        </a:xfrm>
+      </p:grpSpPr>
       <p:sp>
         <p:nvSpPr>
           <p:cNvPr id="2" name="TextBox 1"/>
@@ -3456,7 +3467,7 @@
           <a:noFill/>
         </p:spPr>
         <p:txBody>
-          <a:bodyPr wrap="square" anchor="t" lIns="0" rIns="0" tIns="0" bIns="0">
+          <a:bodyPr wrap="square" lIns="0" tIns="0" rIns="0" bIns="0" anchor="t">
             <a:spAutoFit/>
           </a:bodyPr>
           <a:lstStyle/>
@@ -3498,7 +3509,7 @@
           <a:noFill/>
         </p:spPr>
         <p:txBody>
-          <a:bodyPr wrap="square" anchor="t" lIns="0" rIns="0" tIns="0" bIns="0">
+          <a:bodyPr wrap="square" lIns="0" tIns="0" rIns="0" bIns="0" anchor="t">
             <a:spAutoFit/>
           </a:bodyPr>
           <a:lstStyle/>
@@ -3568,6 +3579,7 @@
           <a:lstStyle/>
           <a:p>
             <a:pPr algn="ctr"/>
+            <a:endParaRPr/>
           </a:p>
         </p:txBody>
       </p:sp>
@@ -3610,7 +3622,7 @@
           </a:fontRef>
         </p:style>
         <p:txBody>
-          <a:bodyPr rtlCol="0" anchor="ctr" lIns="0" rIns="0" tIns="0" bIns="0"/>
+          <a:bodyPr lIns="0" tIns="0" rIns="0" bIns="0" rtlCol="0" anchor="ctr"/>
           <a:lstStyle/>
           <a:p>
             <a:pPr algn="ctr"/>
@@ -3643,7 +3655,7 @@
           <a:noFill/>
         </p:spPr>
         <p:txBody>
-          <a:bodyPr wrap="square" anchor="t" lIns="0" rIns="0" tIns="0" bIns="0">
+          <a:bodyPr wrap="square" lIns="0" tIns="0" rIns="0" bIns="0" anchor="t">
             <a:spAutoFit/>
           </a:bodyPr>
           <a:lstStyle/>
@@ -3685,7 +3697,7 @@
           <a:noFill/>
         </p:spPr>
         <p:txBody>
-          <a:bodyPr wrap="square" anchor="t" lIns="0" rIns="0" tIns="0" bIns="0">
+          <a:bodyPr wrap="square" lIns="0" tIns="0" rIns="0" bIns="0" anchor="t">
             <a:spAutoFit/>
           </a:bodyPr>
           <a:lstStyle/>
@@ -3773,6 +3785,7 @@
           <a:lstStyle/>
           <a:p>
             <a:pPr algn="ctr"/>
+            <a:endParaRPr/>
           </a:p>
         </p:txBody>
       </p:sp>
@@ -3815,7 +3828,7 @@
           </a:fontRef>
         </p:style>
         <p:txBody>
-          <a:bodyPr rtlCol="0" anchor="ctr" lIns="0" rIns="0" tIns="0" bIns="0"/>
+          <a:bodyPr lIns="0" tIns="0" rIns="0" bIns="0" rtlCol="0" anchor="ctr"/>
           <a:lstStyle/>
           <a:p>
             <a:pPr algn="ctr"/>
@@ -3848,7 +3861,7 @@
           <a:noFill/>
         </p:spPr>
         <p:txBody>
-          <a:bodyPr wrap="square" anchor="t" lIns="0" rIns="0" tIns="0" bIns="0">
+          <a:bodyPr wrap="square" lIns="0" tIns="0" rIns="0" bIns="0" anchor="t">
             <a:spAutoFit/>
           </a:bodyPr>
           <a:lstStyle/>
@@ -3890,7 +3903,7 @@
           <a:noFill/>
         </p:spPr>
         <p:txBody>
-          <a:bodyPr wrap="square" anchor="t" lIns="0" rIns="0" tIns="0" bIns="0">
+          <a:bodyPr wrap="square" lIns="0" tIns="0" rIns="0" bIns="0" anchor="t">
             <a:spAutoFit/>
           </a:bodyPr>
           <a:lstStyle/>
@@ -4070,6 +4083,7 @@
           <a:lstStyle/>
           <a:p>
             <a:pPr algn="ctr"/>
+            <a:endParaRPr/>
           </a:p>
         </p:txBody>
       </p:sp>
@@ -4112,7 +4126,7 @@
           </a:fontRef>
         </p:style>
         <p:txBody>
-          <a:bodyPr rtlCol="0" anchor="ctr" lIns="0" rIns="0" tIns="0" bIns="0"/>
+          <a:bodyPr lIns="0" tIns="0" rIns="0" bIns="0" rtlCol="0" anchor="ctr"/>
           <a:lstStyle/>
           <a:p>
             <a:pPr algn="ctr"/>
@@ -4145,7 +4159,7 @@
           <a:noFill/>
         </p:spPr>
         <p:txBody>
-          <a:bodyPr wrap="square" anchor="t" lIns="0" rIns="0" tIns="0" bIns="0">
+          <a:bodyPr wrap="square" lIns="0" tIns="0" rIns="0" bIns="0" anchor="t">
             <a:spAutoFit/>
           </a:bodyPr>
           <a:lstStyle/>
@@ -4187,7 +4201,7 @@
           <a:noFill/>
         </p:spPr>
         <p:txBody>
-          <a:bodyPr wrap="square" anchor="t" lIns="0" rIns="0" tIns="0" bIns="0">
+          <a:bodyPr wrap="square" lIns="0" tIns="0" rIns="0" bIns="0" anchor="t">
             <a:spAutoFit/>
           </a:bodyPr>
           <a:lstStyle/>
@@ -4248,7 +4262,7 @@
           <a:noFill/>
         </p:spPr>
         <p:txBody>
-          <a:bodyPr wrap="square" anchor="t" lIns="0" rIns="0" tIns="0" bIns="0">
+          <a:bodyPr wrap="square" lIns="0" tIns="0" rIns="0" bIns="0" anchor="t">
             <a:spAutoFit/>
           </a:bodyPr>
           <a:lstStyle/>
@@ -4312,7 +4326,7 @@
           </a:fontRef>
         </p:style>
         <p:txBody>
-          <a:bodyPr rtlCol="0" anchor="ctr" lIns="76200" rIns="76200" tIns="0" bIns="0" wrap="none"/>
+          <a:bodyPr wrap="none" lIns="76200" tIns="0" rIns="76200" bIns="0" rtlCol="0" anchor="ctr"/>
           <a:lstStyle/>
           <a:p>
             <a:pPr algn="ctr"/>
@@ -4367,7 +4381,7 @@
           </a:fontRef>
         </p:style>
         <p:txBody>
-          <a:bodyPr rtlCol="0" anchor="ctr" lIns="76200" rIns="76200" tIns="0" bIns="0" wrap="none"/>
+          <a:bodyPr wrap="none" lIns="76200" tIns="0" rIns="76200" bIns="0" rtlCol="0" anchor="ctr"/>
           <a:lstStyle/>
           <a:p>
             <a:pPr algn="ctr"/>
@@ -4422,7 +4436,7 @@
           </a:fontRef>
         </p:style>
         <p:txBody>
-          <a:bodyPr rtlCol="0" anchor="ctr" lIns="76200" rIns="76200" tIns="0" bIns="0" wrap="none"/>
+          <a:bodyPr wrap="none" lIns="76200" tIns="0" rIns="76200" bIns="0" rtlCol="0" anchor="ctr"/>
           <a:lstStyle/>
           <a:p>
             <a:pPr algn="ctr"/>
@@ -4477,7 +4491,7 @@
           </a:fontRef>
         </p:style>
         <p:txBody>
-          <a:bodyPr rtlCol="0" anchor="ctr" lIns="177800" tIns="101600"/>
+          <a:bodyPr lIns="177800" tIns="101600" rtlCol="0" anchor="ctr"/>
           <a:lstStyle/>
           <a:p>
             <a:pPr algn="ctr"/>
@@ -4537,7 +4551,7 @@
           <a:noFill/>
         </p:spPr>
         <p:txBody>
-          <a:bodyPr wrap="square" anchor="t" lIns="0" rIns="0" tIns="0" bIns="0">
+          <a:bodyPr wrap="square" lIns="0" tIns="0" rIns="0" bIns="0" anchor="t">
             <a:spAutoFit/>
           </a:bodyPr>
           <a:lstStyle/>
@@ -4579,7 +4593,7 @@
           <a:noFill/>
         </p:spPr>
         <p:txBody>
-          <a:bodyPr wrap="square" anchor="t" lIns="0" rIns="0" tIns="0" bIns="0">
+          <a:bodyPr wrap="square" lIns="0" tIns="0" rIns="0" bIns="0" anchor="t">
             <a:spAutoFit/>
           </a:bodyPr>
           <a:lstStyle/>
@@ -4613,7 +4627,7 @@
 </file>
 
 <file path=ppt/slides/slide3.xml><?xml version="1.0" encoding="utf-8"?>
-<p:sld xmlns:a="http://schemas.openxmlformats.org/drawingml/2006/main" xmlns:p="http://schemas.openxmlformats.org/presentationml/2006/main" xmlns:r="http://schemas.openxmlformats.org/officeDocument/2006/relationships">
+<p:sld xmlns:a="http://schemas.openxmlformats.org/drawingml/2006/main" xmlns:r="http://schemas.openxmlformats.org/officeDocument/2006/relationships" xmlns:p="http://schemas.openxmlformats.org/presentationml/2006/main">
   <p:cSld>
     <p:bg>
       <p:bgPr>
@@ -4629,7 +4643,14 @@
         <p:cNvGrpSpPr/>
         <p:nvPr/>
       </p:nvGrpSpPr>
-      <p:grpSpPr/>
+      <p:grpSpPr>
+        <a:xfrm>
+          <a:off x="0" y="0"/>
+          <a:ext cx="0" cy="0"/>
+          <a:chOff x="0" y="0"/>
+          <a:chExt cx="0" cy="0"/>
+        </a:xfrm>
+      </p:grpSpPr>
       <p:sp>
         <p:nvSpPr>
           <p:cNvPr id="2" name="TextBox 1"/>
@@ -4647,7 +4668,7 @@
           <a:noFill/>
         </p:spPr>
         <p:txBody>
-          <a:bodyPr wrap="square" anchor="t" lIns="0" rIns="0" tIns="0" bIns="0">
+          <a:bodyPr wrap="square" lIns="0" tIns="0" rIns="0" bIns="0" anchor="t">
             <a:spAutoFit/>
           </a:bodyPr>
           <a:lstStyle/>
@@ -4689,7 +4710,7 @@
           <a:noFill/>
         </p:spPr>
         <p:txBody>
-          <a:bodyPr wrap="square" anchor="t" lIns="0" rIns="0" tIns="0" bIns="0">
+          <a:bodyPr wrap="square" lIns="0" tIns="0" rIns="0" bIns="0" anchor="t">
             <a:spAutoFit/>
           </a:bodyPr>
           <a:lstStyle/>
@@ -4759,6 +4780,7 @@
           <a:lstStyle/>
           <a:p>
             <a:pPr algn="ctr"/>
+            <a:endParaRPr/>
           </a:p>
         </p:txBody>
       </p:sp>
@@ -4779,7 +4801,7 @@
           <a:noFill/>
         </p:spPr>
         <p:txBody>
-          <a:bodyPr wrap="square" anchor="t" lIns="0" rIns="0" tIns="0" bIns="0">
+          <a:bodyPr wrap="square" lIns="0" tIns="0" rIns="0" bIns="0" anchor="t">
             <a:spAutoFit/>
           </a:bodyPr>
           <a:lstStyle/>
@@ -4821,7 +4843,7 @@
           <a:noFill/>
         </p:spPr>
         <p:txBody>
-          <a:bodyPr wrap="square" anchor="t" lIns="0" rIns="0" tIns="0" bIns="0">
+          <a:bodyPr wrap="square" lIns="0" tIns="0" rIns="0" bIns="0" anchor="t">
             <a:spAutoFit/>
           </a:bodyPr>
           <a:lstStyle/>
@@ -4863,7 +4885,7 @@
           <a:noFill/>
         </p:spPr>
         <p:txBody>
-          <a:bodyPr wrap="square" anchor="t" lIns="0" rIns="0" tIns="0" bIns="0">
+          <a:bodyPr wrap="square" lIns="0" tIns="0" rIns="0" bIns="0" anchor="t">
             <a:spAutoFit/>
           </a:bodyPr>
           <a:lstStyle/>
@@ -4905,7 +4927,7 @@
           <a:noFill/>
         </p:spPr>
         <p:txBody>
-          <a:bodyPr wrap="square" anchor="ctr" lIns="0" rIns="0" tIns="0" bIns="0">
+          <a:bodyPr wrap="square" lIns="0" tIns="0" rIns="0" bIns="0" anchor="ctr">
             <a:spAutoFit/>
           </a:bodyPr>
           <a:lstStyle/>
@@ -4975,6 +4997,7 @@
           <a:lstStyle/>
           <a:p>
             <a:pPr algn="ctr"/>
+            <a:endParaRPr/>
           </a:p>
         </p:txBody>
       </p:sp>
@@ -4995,7 +5018,7 @@
           <a:noFill/>
         </p:spPr>
         <p:txBody>
-          <a:bodyPr wrap="square" anchor="t" lIns="0" rIns="0" tIns="0" bIns="0">
+          <a:bodyPr wrap="square" lIns="0" tIns="0" rIns="0" bIns="0" anchor="t">
             <a:spAutoFit/>
           </a:bodyPr>
           <a:lstStyle/>
@@ -5037,7 +5060,7 @@
           <a:noFill/>
         </p:spPr>
         <p:txBody>
-          <a:bodyPr wrap="square" anchor="t" lIns="0" rIns="0" tIns="0" bIns="0">
+          <a:bodyPr wrap="square" lIns="0" tIns="0" rIns="0" bIns="0" anchor="t">
             <a:spAutoFit/>
           </a:bodyPr>
           <a:lstStyle/>
@@ -5079,7 +5102,7 @@
           <a:noFill/>
         </p:spPr>
         <p:txBody>
-          <a:bodyPr wrap="square" anchor="t" lIns="0" rIns="0" tIns="0" bIns="0">
+          <a:bodyPr wrap="square" lIns="0" tIns="0" rIns="0" bIns="0" anchor="t">
             <a:spAutoFit/>
           </a:bodyPr>
           <a:lstStyle/>
@@ -5121,7 +5144,7 @@
           <a:noFill/>
         </p:spPr>
         <p:txBody>
-          <a:bodyPr wrap="square" anchor="ctr" lIns="0" rIns="0" tIns="0" bIns="0">
+          <a:bodyPr wrap="square" lIns="0" tIns="0" rIns="0" bIns="0" anchor="ctr">
             <a:spAutoFit/>
           </a:bodyPr>
           <a:lstStyle/>
@@ -5191,6 +5214,7 @@
           <a:lstStyle/>
           <a:p>
             <a:pPr algn="ctr"/>
+            <a:endParaRPr/>
           </a:p>
         </p:txBody>
       </p:sp>
@@ -5211,7 +5235,7 @@
           <a:noFill/>
         </p:spPr>
         <p:txBody>
-          <a:bodyPr wrap="square" anchor="t" lIns="0" rIns="0" tIns="0" bIns="0">
+          <a:bodyPr wrap="square" lIns="0" tIns="0" rIns="0" bIns="0" anchor="t">
             <a:spAutoFit/>
           </a:bodyPr>
           <a:lstStyle/>
@@ -5253,7 +5277,7 @@
           <a:noFill/>
         </p:spPr>
         <p:txBody>
-          <a:bodyPr wrap="square" anchor="t" lIns="0" rIns="0" tIns="0" bIns="0">
+          <a:bodyPr wrap="square" lIns="0" tIns="0" rIns="0" bIns="0" anchor="t">
             <a:spAutoFit/>
           </a:bodyPr>
           <a:lstStyle/>
@@ -5295,7 +5319,7 @@
           <a:noFill/>
         </p:spPr>
         <p:txBody>
-          <a:bodyPr wrap="square" anchor="t" lIns="0" rIns="0" tIns="0" bIns="0">
+          <a:bodyPr wrap="square" lIns="0" tIns="0" rIns="0" bIns="0" anchor="t">
             <a:spAutoFit/>
           </a:bodyPr>
           <a:lstStyle/>
@@ -5337,7 +5361,7 @@
           <a:noFill/>
         </p:spPr>
         <p:txBody>
-          <a:bodyPr wrap="square" anchor="ctr" lIns="0" rIns="0" tIns="0" bIns="0">
+          <a:bodyPr wrap="square" lIns="0" tIns="0" rIns="0" bIns="0" anchor="ctr">
             <a:spAutoFit/>
           </a:bodyPr>
           <a:lstStyle/>
@@ -5407,6 +5431,7 @@
           <a:lstStyle/>
           <a:p>
             <a:pPr algn="ctr"/>
+            <a:endParaRPr/>
           </a:p>
         </p:txBody>
       </p:sp>
@@ -5427,7 +5452,7 @@
           <a:noFill/>
         </p:spPr>
         <p:txBody>
-          <a:bodyPr wrap="square" anchor="t" lIns="0" rIns="0" tIns="0" bIns="0">
+          <a:bodyPr wrap="square" lIns="0" tIns="0" rIns="0" bIns="0" anchor="t">
             <a:spAutoFit/>
           </a:bodyPr>
           <a:lstStyle/>
@@ -5469,7 +5494,7 @@
           <a:noFill/>
         </p:spPr>
         <p:txBody>
-          <a:bodyPr wrap="square" anchor="t" lIns="0" rIns="0" tIns="0" bIns="0">
+          <a:bodyPr wrap="square" lIns="0" tIns="0" rIns="0" bIns="0" anchor="t">
             <a:spAutoFit/>
           </a:bodyPr>
           <a:lstStyle/>
@@ -5511,7 +5536,7 @@
           <a:noFill/>
         </p:spPr>
         <p:txBody>
-          <a:bodyPr wrap="square" anchor="t" lIns="0" rIns="0" tIns="0" bIns="0">
+          <a:bodyPr wrap="square" lIns="0" tIns="0" rIns="0" bIns="0" anchor="t">
             <a:spAutoFit/>
           </a:bodyPr>
           <a:lstStyle/>
@@ -5553,7 +5578,7 @@
           <a:noFill/>
         </p:spPr>
         <p:txBody>
-          <a:bodyPr wrap="square" anchor="ctr" lIns="0" rIns="0" tIns="0" bIns="0">
+          <a:bodyPr wrap="square" lIns="0" tIns="0" rIns="0" bIns="0" anchor="ctr">
             <a:spAutoFit/>
           </a:bodyPr>
           <a:lstStyle/>
@@ -5623,6 +5648,7 @@
           <a:lstStyle/>
           <a:p>
             <a:pPr algn="ctr"/>
+            <a:endParaRPr/>
           </a:p>
         </p:txBody>
       </p:sp>
@@ -5643,7 +5669,7 @@
           <a:noFill/>
         </p:spPr>
         <p:txBody>
-          <a:bodyPr wrap="square" anchor="t" lIns="0" rIns="0" tIns="0" bIns="0">
+          <a:bodyPr wrap="square" lIns="0" tIns="0" rIns="0" bIns="0" anchor="t">
             <a:spAutoFit/>
           </a:bodyPr>
           <a:lstStyle/>
@@ -5685,7 +5711,7 @@
           <a:noFill/>
         </p:spPr>
         <p:txBody>
-          <a:bodyPr wrap="square" anchor="t" lIns="0" rIns="0" tIns="0" bIns="0">
+          <a:bodyPr wrap="square" lIns="0" tIns="0" rIns="0" bIns="0" anchor="t">
             <a:spAutoFit/>
           </a:bodyPr>
           <a:lstStyle/>
@@ -5727,7 +5753,7 @@
           <a:noFill/>
         </p:spPr>
         <p:txBody>
-          <a:bodyPr wrap="square" anchor="t" lIns="0" rIns="0" tIns="0" bIns="0">
+          <a:bodyPr wrap="square" lIns="0" tIns="0" rIns="0" bIns="0" anchor="t">
             <a:spAutoFit/>
           </a:bodyPr>
           <a:lstStyle/>
@@ -5769,7 +5795,7 @@
           <a:noFill/>
         </p:spPr>
         <p:txBody>
-          <a:bodyPr wrap="square" anchor="ctr" lIns="0" rIns="0" tIns="0" bIns="0">
+          <a:bodyPr wrap="square" lIns="0" tIns="0" rIns="0" bIns="0" anchor="ctr">
             <a:spAutoFit/>
           </a:bodyPr>
           <a:lstStyle/>
@@ -5839,6 +5865,7 @@
           <a:lstStyle/>
           <a:p>
             <a:pPr algn="ctr"/>
+            <a:endParaRPr/>
           </a:p>
         </p:txBody>
       </p:sp>
@@ -5859,7 +5886,7 @@
           <a:noFill/>
         </p:spPr>
         <p:txBody>
-          <a:bodyPr wrap="square" anchor="t" lIns="0" rIns="0" tIns="0" bIns="0">
+          <a:bodyPr wrap="square" lIns="0" tIns="0" rIns="0" bIns="0" anchor="t">
             <a:spAutoFit/>
           </a:bodyPr>
           <a:lstStyle/>
@@ -5901,7 +5928,7 @@
           <a:noFill/>
         </p:spPr>
         <p:txBody>
-          <a:bodyPr wrap="square" anchor="t" lIns="0" rIns="0" tIns="0" bIns="0">
+          <a:bodyPr wrap="square" lIns="0" tIns="0" rIns="0" bIns="0" anchor="t">
             <a:spAutoFit/>
           </a:bodyPr>
           <a:lstStyle/>
@@ -5943,7 +5970,7 @@
           <a:noFill/>
         </p:spPr>
         <p:txBody>
-          <a:bodyPr wrap="square" anchor="t" lIns="0" rIns="0" tIns="0" bIns="0">
+          <a:bodyPr wrap="square" lIns="0" tIns="0" rIns="0" bIns="0" anchor="t">
             <a:spAutoFit/>
           </a:bodyPr>
           <a:lstStyle/>
@@ -5985,7 +6012,7 @@
           <a:noFill/>
         </p:spPr>
         <p:txBody>
-          <a:bodyPr wrap="square" anchor="ctr" lIns="0" rIns="0" tIns="0" bIns="0">
+          <a:bodyPr wrap="square" lIns="0" tIns="0" rIns="0" bIns="0" anchor="ctr">
             <a:spAutoFit/>
           </a:bodyPr>
           <a:lstStyle/>
@@ -6055,6 +6082,7 @@
           <a:lstStyle/>
           <a:p>
             <a:pPr algn="ctr"/>
+            <a:endParaRPr/>
           </a:p>
         </p:txBody>
       </p:sp>
@@ -6075,7 +6103,7 @@
           <a:noFill/>
         </p:spPr>
         <p:txBody>
-          <a:bodyPr wrap="square" anchor="t" lIns="0" rIns="0" tIns="0" bIns="0">
+          <a:bodyPr wrap="square" lIns="0" tIns="0" rIns="0" bIns="0" anchor="t">
             <a:spAutoFit/>
           </a:bodyPr>
           <a:lstStyle/>
@@ -6117,7 +6145,7 @@
           <a:noFill/>
         </p:spPr>
         <p:txBody>
-          <a:bodyPr wrap="square" anchor="t" lIns="0" rIns="0" tIns="0" bIns="0">
+          <a:bodyPr wrap="square" lIns="0" tIns="0" rIns="0" bIns="0" anchor="t">
             <a:spAutoFit/>
           </a:bodyPr>
           <a:lstStyle/>
@@ -6159,7 +6187,7 @@
           <a:noFill/>
         </p:spPr>
         <p:txBody>
-          <a:bodyPr wrap="square" anchor="t" lIns="0" rIns="0" tIns="0" bIns="0">
+          <a:bodyPr wrap="square" lIns="0" tIns="0" rIns="0" bIns="0" anchor="t">
             <a:spAutoFit/>
           </a:bodyPr>
           <a:lstStyle/>
@@ -6201,7 +6229,7 @@
           <a:noFill/>
         </p:spPr>
         <p:txBody>
-          <a:bodyPr wrap="square" anchor="ctr" lIns="0" rIns="0" tIns="0" bIns="0">
+          <a:bodyPr wrap="square" lIns="0" tIns="0" rIns="0" bIns="0" anchor="ctr">
             <a:spAutoFit/>
           </a:bodyPr>
           <a:lstStyle/>
@@ -6243,7 +6271,7 @@
           <a:noFill/>
         </p:spPr>
         <p:txBody>
-          <a:bodyPr wrap="square" anchor="t" lIns="0" rIns="0" tIns="0" bIns="0">
+          <a:bodyPr wrap="square" lIns="0" tIns="0" rIns="0" bIns="0" anchor="t">
             <a:spAutoFit/>
           </a:bodyPr>
           <a:lstStyle/>
@@ -6285,7 +6313,7 @@
           <a:noFill/>
         </p:spPr>
         <p:txBody>
-          <a:bodyPr wrap="square" anchor="t" lIns="0" rIns="0" tIns="0" bIns="0">
+          <a:bodyPr wrap="square" lIns="0" tIns="0" rIns="0" bIns="0" anchor="t">
             <a:spAutoFit/>
           </a:bodyPr>
           <a:lstStyle/>
@@ -6319,7 +6347,7 @@
 </file>
 
 <file path=ppt/slides/slide4.xml><?xml version="1.0" encoding="utf-8"?>
-<p:sld xmlns:a="http://schemas.openxmlformats.org/drawingml/2006/main" xmlns:p="http://schemas.openxmlformats.org/presentationml/2006/main" xmlns:r="http://schemas.openxmlformats.org/officeDocument/2006/relationships">
+<p:sld xmlns:a="http://schemas.openxmlformats.org/drawingml/2006/main" xmlns:r="http://schemas.openxmlformats.org/officeDocument/2006/relationships" xmlns:p="http://schemas.openxmlformats.org/presentationml/2006/main">
   <p:cSld>
     <p:bg>
       <p:bgPr>
@@ -6335,7 +6363,14 @@
         <p:cNvGrpSpPr/>
         <p:nvPr/>
       </p:nvGrpSpPr>
-      <p:grpSpPr/>
+      <p:grpSpPr>
+        <a:xfrm>
+          <a:off x="0" y="0"/>
+          <a:ext cx="0" cy="0"/>
+          <a:chOff x="0" y="0"/>
+          <a:chExt cx="0" cy="0"/>
+        </a:xfrm>
+      </p:grpSpPr>
       <p:sp>
         <p:nvSpPr>
           <p:cNvPr id="2" name="TextBox 1"/>
@@ -6353,7 +6388,7 @@
           <a:noFill/>
         </p:spPr>
         <p:txBody>
-          <a:bodyPr wrap="square" anchor="t" lIns="0" rIns="0" tIns="0" bIns="0">
+          <a:bodyPr wrap="square" lIns="0" tIns="0" rIns="0" bIns="0" anchor="t">
             <a:spAutoFit/>
           </a:bodyPr>
           <a:lstStyle/>
@@ -6395,7 +6430,7 @@
           <a:noFill/>
         </p:spPr>
         <p:txBody>
-          <a:bodyPr wrap="square" anchor="t" lIns="0" rIns="0" tIns="0" bIns="0">
+          <a:bodyPr wrap="square" lIns="0" tIns="0" rIns="0" bIns="0" anchor="t">
             <a:spAutoFit/>
           </a:bodyPr>
           <a:lstStyle/>
@@ -6465,6 +6500,7 @@
           <a:lstStyle/>
           <a:p>
             <a:pPr algn="ctr"/>
+            <a:endParaRPr/>
           </a:p>
         </p:txBody>
       </p:sp>
@@ -6507,7 +6543,7 @@
           </a:fontRef>
         </p:style>
         <p:txBody>
-          <a:bodyPr rtlCol="0" anchor="ctr" lIns="0" rIns="0" tIns="0" bIns="0"/>
+          <a:bodyPr lIns="0" tIns="0" rIns="0" bIns="0" rtlCol="0" anchor="ctr"/>
           <a:lstStyle/>
           <a:p>
             <a:pPr algn="ctr"/>
@@ -6540,7 +6576,7 @@
           <a:noFill/>
         </p:spPr>
         <p:txBody>
-          <a:bodyPr wrap="square" anchor="ctr" lIns="0" rIns="0" tIns="0" bIns="0">
+          <a:bodyPr wrap="square" lIns="0" tIns="0" rIns="0" bIns="0" anchor="ctr">
             <a:spAutoFit/>
           </a:bodyPr>
           <a:lstStyle/>
@@ -6582,7 +6618,7 @@
           <a:noFill/>
         </p:spPr>
         <p:txBody>
-          <a:bodyPr wrap="square" anchor="ctr" lIns="0" rIns="0" tIns="0" bIns="0">
+          <a:bodyPr wrap="square" lIns="0" tIns="0" rIns="0" bIns="0" anchor="ctr">
             <a:spAutoFit/>
           </a:bodyPr>
           <a:lstStyle/>
@@ -6652,6 +6688,7 @@
           <a:lstStyle/>
           <a:p>
             <a:pPr algn="ctr"/>
+            <a:endParaRPr/>
           </a:p>
         </p:txBody>
       </p:sp>
@@ -6694,7 +6731,7 @@
           </a:fontRef>
         </p:style>
         <p:txBody>
-          <a:bodyPr rtlCol="0" anchor="ctr" lIns="0" rIns="0" tIns="0" bIns="0"/>
+          <a:bodyPr lIns="0" tIns="0" rIns="0" bIns="0" rtlCol="0" anchor="ctr"/>
           <a:lstStyle/>
           <a:p>
             <a:pPr algn="ctr"/>
@@ -6727,7 +6764,7 @@
           <a:noFill/>
         </p:spPr>
         <p:txBody>
-          <a:bodyPr wrap="square" anchor="ctr" lIns="0" rIns="0" tIns="0" bIns="0">
+          <a:bodyPr wrap="square" lIns="0" tIns="0" rIns="0" bIns="0" anchor="ctr">
             <a:spAutoFit/>
           </a:bodyPr>
           <a:lstStyle/>
@@ -6769,7 +6806,7 @@
           <a:noFill/>
         </p:spPr>
         <p:txBody>
-          <a:bodyPr wrap="square" anchor="ctr" lIns="0" rIns="0" tIns="0" bIns="0">
+          <a:bodyPr wrap="square" lIns="0" tIns="0" rIns="0" bIns="0" anchor="ctr">
             <a:spAutoFit/>
           </a:bodyPr>
           <a:lstStyle/>
@@ -6839,6 +6876,7 @@
           <a:lstStyle/>
           <a:p>
             <a:pPr algn="ctr"/>
+            <a:endParaRPr/>
           </a:p>
         </p:txBody>
       </p:sp>
@@ -6881,7 +6919,7 @@
           </a:fontRef>
         </p:style>
         <p:txBody>
-          <a:bodyPr rtlCol="0" anchor="ctr" lIns="0" rIns="0" tIns="0" bIns="0"/>
+          <a:bodyPr lIns="0" tIns="0" rIns="0" bIns="0" rtlCol="0" anchor="ctr"/>
           <a:lstStyle/>
           <a:p>
             <a:pPr algn="ctr"/>
@@ -6914,7 +6952,7 @@
           <a:noFill/>
         </p:spPr>
         <p:txBody>
-          <a:bodyPr wrap="square" anchor="ctr" lIns="0" rIns="0" tIns="0" bIns="0">
+          <a:bodyPr wrap="square" lIns="0" tIns="0" rIns="0" bIns="0" anchor="ctr">
             <a:spAutoFit/>
           </a:bodyPr>
           <a:lstStyle/>
@@ -6956,7 +6994,7 @@
           <a:noFill/>
         </p:spPr>
         <p:txBody>
-          <a:bodyPr wrap="square" anchor="ctr" lIns="0" rIns="0" tIns="0" bIns="0">
+          <a:bodyPr wrap="square" lIns="0" tIns="0" rIns="0" bIns="0" anchor="ctr">
             <a:spAutoFit/>
           </a:bodyPr>
           <a:lstStyle/>
@@ -7026,6 +7064,7 @@
           <a:lstStyle/>
           <a:p>
             <a:pPr algn="ctr"/>
+            <a:endParaRPr/>
           </a:p>
         </p:txBody>
       </p:sp>
@@ -7068,7 +7107,7 @@
           </a:fontRef>
         </p:style>
         <p:txBody>
-          <a:bodyPr rtlCol="0" anchor="ctr" lIns="0" rIns="0" tIns="0" bIns="0"/>
+          <a:bodyPr lIns="0" tIns="0" rIns="0" bIns="0" rtlCol="0" anchor="ctr"/>
           <a:lstStyle/>
           <a:p>
             <a:pPr algn="ctr"/>
@@ -7101,7 +7140,7 @@
           <a:noFill/>
         </p:spPr>
         <p:txBody>
-          <a:bodyPr wrap="square" anchor="ctr" lIns="0" rIns="0" tIns="0" bIns="0">
+          <a:bodyPr wrap="square" lIns="0" tIns="0" rIns="0" bIns="0" anchor="ctr">
             <a:spAutoFit/>
           </a:bodyPr>
           <a:lstStyle/>
@@ -7143,7 +7182,7 @@
           <a:noFill/>
         </p:spPr>
         <p:txBody>
-          <a:bodyPr wrap="square" anchor="ctr" lIns="0" rIns="0" tIns="0" bIns="0">
+          <a:bodyPr wrap="square" lIns="0" tIns="0" rIns="0" bIns="0" anchor="ctr">
             <a:spAutoFit/>
           </a:bodyPr>
           <a:lstStyle/>
@@ -7185,7 +7224,7 @@
           <a:noFill/>
         </p:spPr>
         <p:txBody>
-          <a:bodyPr wrap="square" anchor="t" lIns="0" rIns="0" tIns="0" bIns="0">
+          <a:bodyPr wrap="square" lIns="0" tIns="0" rIns="0" bIns="0" anchor="t">
             <a:spAutoFit/>
           </a:bodyPr>
           <a:lstStyle/>
@@ -7227,7 +7266,7 @@
           <a:noFill/>
         </p:spPr>
         <p:txBody>
-          <a:bodyPr wrap="square" anchor="t" lIns="0" rIns="0" tIns="0" bIns="0">
+          <a:bodyPr wrap="square" lIns="0" tIns="0" rIns="0" bIns="0" anchor="t">
             <a:spAutoFit/>
           </a:bodyPr>
           <a:lstStyle/>
@@ -7261,7 +7300,7 @@
 </file>
 
 <file path=ppt/slides/slide5.xml><?xml version="1.0" encoding="utf-8"?>
-<p:sld xmlns:a="http://schemas.openxmlformats.org/drawingml/2006/main" xmlns:p="http://schemas.openxmlformats.org/presentationml/2006/main" xmlns:r="http://schemas.openxmlformats.org/officeDocument/2006/relationships">
+<p:sld xmlns:a="http://schemas.openxmlformats.org/drawingml/2006/main" xmlns:r="http://schemas.openxmlformats.org/officeDocument/2006/relationships" xmlns:p="http://schemas.openxmlformats.org/presentationml/2006/main">
   <p:cSld>
     <p:bg>
       <p:bgPr>
@@ -7277,7 +7316,14 @@
         <p:cNvGrpSpPr/>
         <p:nvPr/>
       </p:nvGrpSpPr>
-      <p:grpSpPr/>
+      <p:grpSpPr>
+        <a:xfrm>
+          <a:off x="0" y="0"/>
+          <a:ext cx="0" cy="0"/>
+          <a:chOff x="0" y="0"/>
+          <a:chExt cx="0" cy="0"/>
+        </a:xfrm>
+      </p:grpSpPr>
       <p:sp>
         <p:nvSpPr>
           <p:cNvPr id="2" name="TextBox 1"/>
@@ -7295,7 +7341,7 @@
           <a:noFill/>
         </p:spPr>
         <p:txBody>
-          <a:bodyPr wrap="square" anchor="t" lIns="0" rIns="0" tIns="0" bIns="0">
+          <a:bodyPr wrap="square" lIns="0" tIns="0" rIns="0" bIns="0" anchor="t">
             <a:spAutoFit/>
           </a:bodyPr>
           <a:lstStyle/>
@@ -7337,7 +7383,7 @@
           <a:noFill/>
         </p:spPr>
         <p:txBody>
-          <a:bodyPr wrap="square" anchor="t" lIns="0" rIns="0" tIns="0" bIns="0">
+          <a:bodyPr wrap="square" lIns="0" tIns="0" rIns="0" bIns="0" anchor="t">
             <a:spAutoFit/>
           </a:bodyPr>
           <a:lstStyle/>
@@ -7407,6 +7453,7 @@
           <a:lstStyle/>
           <a:p>
             <a:pPr algn="ctr"/>
+            <a:endParaRPr/>
           </a:p>
         </p:txBody>
       </p:sp>
@@ -7427,7 +7474,7 @@
           <a:noFill/>
         </p:spPr>
         <p:txBody>
-          <a:bodyPr wrap="square" anchor="t" lIns="0" rIns="0" tIns="0" bIns="0">
+          <a:bodyPr wrap="square" lIns="0" tIns="0" rIns="0" bIns="0" anchor="t">
             <a:spAutoFit/>
           </a:bodyPr>
           <a:lstStyle/>
@@ -7469,7 +7516,7 @@
           <a:noFill/>
         </p:spPr>
         <p:txBody>
-          <a:bodyPr wrap="square" anchor="t" lIns="0" rIns="0" tIns="0" bIns="0">
+          <a:bodyPr wrap="square" lIns="0" tIns="0" rIns="0" bIns="0" anchor="t">
             <a:spAutoFit/>
           </a:bodyPr>
           <a:lstStyle/>
@@ -7539,6 +7586,7 @@
           <a:lstStyle/>
           <a:p>
             <a:pPr algn="ctr"/>
+            <a:endParaRPr/>
           </a:p>
         </p:txBody>
       </p:sp>
@@ -7559,7 +7607,7 @@
           <a:noFill/>
         </p:spPr>
         <p:txBody>
-          <a:bodyPr wrap="square" anchor="t" lIns="0" rIns="0" tIns="0" bIns="0">
+          <a:bodyPr wrap="square" lIns="0" tIns="0" rIns="0" bIns="0" anchor="t">
             <a:spAutoFit/>
           </a:bodyPr>
           <a:lstStyle/>
@@ -7601,7 +7649,7 @@
           <a:noFill/>
         </p:spPr>
         <p:txBody>
-          <a:bodyPr wrap="square" anchor="t" lIns="0" rIns="0" tIns="0" bIns="0">
+          <a:bodyPr wrap="square" lIns="0" tIns="0" rIns="0" bIns="0" anchor="t">
             <a:spAutoFit/>
           </a:bodyPr>
           <a:lstStyle/>
@@ -7669,6 +7717,7 @@
           <a:lstStyle/>
           <a:p>
             <a:pPr algn="ctr"/>
+            <a:endParaRPr/>
           </a:p>
         </p:txBody>
       </p:sp>
@@ -7689,7 +7738,7 @@
           <a:noFill/>
         </p:spPr>
         <p:txBody>
-          <a:bodyPr wrap="square" anchor="t" lIns="0" rIns="0" tIns="0" bIns="0">
+          <a:bodyPr wrap="square" lIns="0" tIns="0" rIns="0" bIns="0" anchor="t">
             <a:spAutoFit/>
           </a:bodyPr>
           <a:lstStyle/>
@@ -7731,7 +7780,7 @@
           <a:noFill/>
         </p:spPr>
         <p:txBody>
-          <a:bodyPr wrap="square" anchor="t" lIns="0" rIns="0" tIns="0" bIns="0">
+          <a:bodyPr wrap="square" lIns="0" tIns="0" rIns="0" bIns="0" anchor="t">
             <a:spAutoFit/>
           </a:bodyPr>
           <a:lstStyle/>
@@ -7791,7 +7840,7 @@
           <a:noFill/>
         </p:spPr>
         <p:txBody>
-          <a:bodyPr wrap="square" anchor="t" lIns="0" rIns="0" tIns="0" bIns="0">
+          <a:bodyPr wrap="square" lIns="0" tIns="0" rIns="0" bIns="0" anchor="t">
             <a:spAutoFit/>
           </a:bodyPr>
           <a:lstStyle/>
@@ -7833,7 +7882,7 @@
           <a:noFill/>
         </p:spPr>
         <p:txBody>
-          <a:bodyPr wrap="square" anchor="t" lIns="0" rIns="0" tIns="0" bIns="0">
+          <a:bodyPr wrap="square" lIns="0" tIns="0" rIns="0" bIns="0" anchor="t">
             <a:spAutoFit/>
           </a:bodyPr>
           <a:lstStyle/>
@@ -8184,4 +8233,10 @@
   </a:objectDefaults>
   <a:extraClrSchemeLst/>
 </a:theme>
+</file>
+
+<file path=docMetadata/LabelInfo.xml><?xml version="1.0" encoding="utf-8"?>
+<clbl:labelList xmlns:clbl="http://schemas.microsoft.com/office/2020/mipLabelMetadata">
+  <clbl:label id="{08e8b0a9-d31e-4c01-8478-c339e5863530}" enabled="1" method="Standard" siteId="{36e1a4fe-f9b7-4356-a5c4-5d6b2e8578b4}" contentBits="0" removed="0"/>
+</clbl:labelList>
 </file>
</xml_diff>